<commit_message>
Harden for public release: terminology, security, and cleanup
- Replace "in-account inference" with "private-connectivity inference via
  PrivateLink" across all agents and docs (technically accurate)
- Remove all railway.toml files (project deploys on AWS, not Railway)
- Remove internal planning docs (CHATGPT-REVIEW-REMEDIATION-PLAN,
  DAVES-CHEAT-SHEET, SLG-PARITY-AND-DEEPENING-PLAN) — all completed
- Remove _slide_review/ temporary artifacts
- Add architecture diagrams (GxP data flow, MCP gateway auth flow)
- Add capability maturity matrix to README
- Add clean-account acceptance evidence (account ID redacted)
- Add scrub_history.sh for purging leaked deploy artifacts
- Update SECURITY.md: GitHub Security Advisories instead of personal email
- Update LICENSE copyright holder
- Add TCO pilot vs production cost summary
- Update .gitignore with .aws-sam/ and _qa*/ exclusions

Co-Authored-By: Claude Opus 4.6 (1M context) <noreply@anthropic.com>
</commit_message>
<xml_diff>
--- a/decks/HCLS-01-Regulatory-Writing.pptx
+++ b/decks/HCLS-01-Regulatory-Writing.pptx
@@ -7714,28 +7714,28 @@
         <a:sysClr val="window" lastClr="FFFFFF"/>
       </a:lt1>
       <a:dk2>
-        <a:srgbClr val="44546A"/>
+        <a:srgbClr val="232F3E"/>
       </a:dk2>
       <a:lt2>
         <a:srgbClr val="E7E6E6"/>
       </a:lt2>
       <a:accent1>
-        <a:srgbClr val="4472C4"/>
+        <a:srgbClr val="FF9900"/>
       </a:accent1>
       <a:accent2>
-        <a:srgbClr val="ED7D31"/>
+        <a:srgbClr val="232F3E"/>
       </a:accent2>
       <a:accent3>
-        <a:srgbClr val="A5A5A5"/>
+        <a:srgbClr val="01A88D"/>
       </a:accent3>
       <a:accent4>
-        <a:srgbClr val="FFC000"/>
+        <a:srgbClr val="8C4FFF"/>
       </a:accent4>
       <a:accent5>
-        <a:srgbClr val="5B9BD5"/>
+        <a:srgbClr val="DD344C"/>
       </a:accent5>
       <a:accent6>
-        <a:srgbClr val="70AD47"/>
+        <a:srgbClr val="ED7100"/>
       </a:accent6>
       <a:hlink>
         <a:srgbClr val="0563C1"/>
@@ -7746,7 +7746,7 @@
     </a:clrScheme>
     <a:fontScheme name="Office">
       <a:majorFont>
-        <a:latin typeface="Calibri Light" panose="020F0302020204030204"/>
+        <a:latin typeface="Amazon Ember" panose="020F0302020204030204"/>
         <a:ea typeface=""/>
         <a:cs typeface=""/>
         <a:font script="Jpan" typeface="游ゴシック Light"/>
@@ -7798,7 +7798,7 @@
         <a:font script="Tfng" typeface="Ebrima"/>
       </a:majorFont>
       <a:minorFont>
-        <a:latin typeface="Calibri" panose="020F0502020204030204"/>
+        <a:latin typeface="Amazon Ember" panose="020F0502020204030204"/>
         <a:ea typeface=""/>
         <a:cs typeface=""/>
         <a:font script="Jpan" typeface="游ゴシック"/>

</xml_diff>

<commit_message>
Restore deck disclaimer + HCLS-native services slides (binary-safe)
Co-Authored-By: Claude Opus 4.6 (1M context) <noreply@anthropic.com>
</commit_message>
<xml_diff>
--- a/decks/HCLS-01-Regulatory-Writing.pptx
+++ b/decks/HCLS-01-Regulatory-Writing.pptx
@@ -11,6 +11,7 @@
     <p:sldId id="259" r:id="rId5"/>
     <p:sldId id="260" r:id="rId6"/>
     <p:sldId id="261" r:id="rId7"/>
+    <p:sldId id="262" r:id="rId13"/>
   </p:sldIdLst>
   <p:notesMasterIdLst>
     <p:notesMasterId r:id="rId8"/>
@@ -1339,6 +1340,10 @@
           </a:solidFill>
           <a:ln/>
         </p:spPr>
+        <p:txBody>
+          <a:bodyPr/>
+          <a:p/>
+        </p:txBody>
       </p:sp>
       <p:sp>
         <p:nvSpPr>
@@ -1535,6 +1540,39 @@
               <a:t>HCLS AI Agent Suite  ·  Built on AWS  ·  June 2026</a:t>
             </a:r>
             <a:endParaRPr lang="en-US" sz="1100" dirty="0"/>
+          </a:p>
+        </p:txBody>
+      </p:sp>
+      <p:sp>
+        <p:nvSpPr>
+          <p:cNvPr id="8" name="TextBox 7"/>
+          <p:cNvSpPr txBox="1"/>
+          <p:nvPr/>
+        </p:nvSpPr>
+        <p:spPr>
+          <a:xfrm>
+            <a:off x="274320" y="6446520"/>
+            <a:ext cx="11643360" cy="365760"/>
+          </a:xfrm>
+          <a:prstGeom prst="rect">
+            <a:avLst/>
+          </a:prstGeom>
+          <a:noFill/>
+        </p:spPr>
+        <p:txBody>
+          <a:bodyPr wrap="square">
+            <a:spAutoFit/>
+          </a:bodyPr>
+          <a:lstStyle/>
+          <a:p>
+            <a:r>
+              <a:rPr sz="750">
+                <a:solidFill>
+                  <a:srgbClr val="B0B8C0"/>
+                </a:solidFill>
+              </a:rPr>
+              <a:t>Reference accelerator - not an AWS service or certification. Built on AWS; not AWS-affiliated/endorsed.</a:t>
+            </a:r>
           </a:p>
         </p:txBody>
       </p:sp>
@@ -1589,6 +1627,10 @@
           </a:solidFill>
           <a:ln/>
         </p:spPr>
+        <p:txBody>
+          <a:bodyPr/>
+          <a:p/>
+        </p:txBody>
       </p:sp>
       <p:sp>
         <p:nvSpPr>
@@ -1737,6 +1779,10 @@
             <a:prstDash val="solid"/>
           </a:ln>
         </p:spPr>
+        <p:txBody>
+          <a:bodyPr/>
+          <a:p/>
+        </p:txBody>
       </p:sp>
       <p:sp>
         <p:nvSpPr>
@@ -1885,6 +1931,10 @@
             <a:prstDash val="solid"/>
           </a:ln>
         </p:spPr>
+        <p:txBody>
+          <a:bodyPr/>
+          <a:p/>
+        </p:txBody>
       </p:sp>
       <p:sp>
         <p:nvSpPr>
@@ -2033,6 +2083,10 @@
             <a:prstDash val="solid"/>
           </a:ln>
         </p:spPr>
+        <p:txBody>
+          <a:bodyPr/>
+          <a:p/>
+        </p:txBody>
       </p:sp>
       <p:sp>
         <p:nvSpPr>
@@ -2247,6 +2301,10 @@
           </a:solidFill>
           <a:ln/>
         </p:spPr>
+        <p:txBody>
+          <a:bodyPr/>
+          <a:p/>
+        </p:txBody>
       </p:sp>
       <p:sp>
         <p:nvSpPr>
@@ -2313,6 +2371,10 @@
             </a:outerShdw>
           </a:effectLst>
         </p:spPr>
+        <p:txBody>
+          <a:bodyPr/>
+          <a:p/>
+        </p:txBody>
       </p:sp>
       <p:sp>
         <p:nvSpPr>
@@ -2333,6 +2395,10 @@
           </a:solidFill>
           <a:ln/>
         </p:spPr>
+        <p:txBody>
+          <a:bodyPr/>
+          <a:p/>
+        </p:txBody>
       </p:sp>
       <p:sp>
         <p:nvSpPr>
@@ -2517,6 +2583,10 @@
             </a:outerShdw>
           </a:effectLst>
         </p:spPr>
+        <p:txBody>
+          <a:bodyPr/>
+          <a:p/>
+        </p:txBody>
       </p:sp>
       <p:sp>
         <p:nvSpPr>
@@ -2537,6 +2607,10 @@
           </a:solidFill>
           <a:ln/>
         </p:spPr>
+        <p:txBody>
+          <a:bodyPr/>
+          <a:p/>
+        </p:txBody>
       </p:sp>
       <p:sp>
         <p:nvSpPr>
@@ -2786,6 +2860,10 @@
           </a:solidFill>
           <a:ln/>
         </p:spPr>
+        <p:txBody>
+          <a:bodyPr/>
+          <a:p/>
+        </p:txBody>
       </p:sp>
       <p:sp>
         <p:nvSpPr>
@@ -2936,6 +3014,10 @@
           </a:solidFill>
           <a:ln/>
         </p:spPr>
+        <p:txBody>
+          <a:bodyPr/>
+          <a:p/>
+        </p:txBody>
       </p:sp>
       <p:sp>
         <p:nvSpPr>
@@ -3044,6 +3126,10 @@
             </a:outerShdw>
           </a:effectLst>
         </p:spPr>
+        <p:txBody>
+          <a:bodyPr/>
+          <a:p/>
+        </p:txBody>
       </p:sp>
       <p:sp>
         <p:nvSpPr>
@@ -3233,6 +3319,10 @@
             </a:outerShdw>
           </a:effectLst>
         </p:spPr>
+        <p:txBody>
+          <a:bodyPr/>
+          <a:p/>
+        </p:txBody>
       </p:sp>
       <p:sp>
         <p:nvSpPr>
@@ -3422,6 +3512,10 @@
             </a:outerShdw>
           </a:effectLst>
         </p:spPr>
+        <p:txBody>
+          <a:bodyPr/>
+          <a:p/>
+        </p:txBody>
       </p:sp>
       <p:sp>
         <p:nvSpPr>
@@ -3611,6 +3705,10 @@
             </a:outerShdw>
           </a:effectLst>
         </p:spPr>
+        <p:txBody>
+          <a:bodyPr/>
+          <a:p/>
+        </p:txBody>
       </p:sp>
       <p:sp>
         <p:nvSpPr>
@@ -3800,6 +3898,10 @@
             </a:outerShdw>
           </a:effectLst>
         </p:spPr>
+        <p:txBody>
+          <a:bodyPr/>
+          <a:p/>
+        </p:txBody>
       </p:sp>
       <p:sp>
         <p:nvSpPr>
@@ -3950,6 +4052,10 @@
             </a:outerShdw>
           </a:effectLst>
         </p:spPr>
+        <p:txBody>
+          <a:bodyPr/>
+          <a:p/>
+        </p:txBody>
       </p:sp>
       <p:sp>
         <p:nvSpPr>
@@ -3970,6 +4076,10 @@
           </a:solidFill>
           <a:ln/>
         </p:spPr>
+        <p:txBody>
+          <a:bodyPr/>
+          <a:p/>
+        </p:txBody>
       </p:sp>
       <p:sp>
         <p:nvSpPr>
@@ -4078,6 +4188,10 @@
             </a:outerShdw>
           </a:effectLst>
         </p:spPr>
+        <p:txBody>
+          <a:bodyPr/>
+          <a:p/>
+        </p:txBody>
       </p:sp>
       <p:sp>
         <p:nvSpPr>
@@ -4098,6 +4212,10 @@
           </a:solidFill>
           <a:ln/>
         </p:spPr>
+        <p:txBody>
+          <a:bodyPr/>
+          <a:p/>
+        </p:txBody>
       </p:sp>
       <p:sp>
         <p:nvSpPr>
@@ -4206,6 +4324,10 @@
             </a:outerShdw>
           </a:effectLst>
         </p:spPr>
+        <p:txBody>
+          <a:bodyPr/>
+          <a:p/>
+        </p:txBody>
       </p:sp>
       <p:sp>
         <p:nvSpPr>
@@ -4226,6 +4348,10 @@
           </a:solidFill>
           <a:ln/>
         </p:spPr>
+        <p:txBody>
+          <a:bodyPr/>
+          <a:p/>
+        </p:txBody>
       </p:sp>
       <p:sp>
         <p:nvSpPr>
@@ -4398,6 +4524,10 @@
           </a:solidFill>
           <a:ln/>
         </p:spPr>
+        <p:txBody>
+          <a:bodyPr/>
+          <a:p/>
+        </p:txBody>
       </p:sp>
       <p:sp>
         <p:nvSpPr>
@@ -4459,6 +4589,10 @@
             <a:prstDash val="dash"/>
           </a:ln>
         </p:spPr>
+        <p:txBody>
+          <a:bodyPr/>
+          <a:p/>
+        </p:txBody>
       </p:sp>
       <p:sp>
         <p:nvSpPr>
@@ -4518,6 +4652,10 @@
           </a:solidFill>
           <a:ln/>
         </p:spPr>
+        <p:txBody>
+          <a:bodyPr/>
+          <a:p/>
+        </p:txBody>
       </p:sp>
       <p:sp>
         <p:nvSpPr>
@@ -4580,6 +4718,10 @@
           </a:solidFill>
           <a:ln/>
         </p:spPr>
+        <p:txBody>
+          <a:bodyPr/>
+          <a:p/>
+        </p:txBody>
       </p:sp>
       <p:sp>
         <p:nvSpPr>
@@ -4662,6 +4804,10 @@
           </a:solidFill>
           <a:ln/>
         </p:spPr>
+        <p:txBody>
+          <a:bodyPr/>
+          <a:p/>
+        </p:txBody>
       </p:sp>
       <p:sp>
         <p:nvSpPr>
@@ -4744,6 +4890,10 @@
           </a:solidFill>
           <a:ln/>
         </p:spPr>
+        <p:txBody>
+          <a:bodyPr/>
+          <a:p/>
+        </p:txBody>
       </p:sp>
       <p:sp>
         <p:nvSpPr>
@@ -4847,6 +4997,10 @@
             <a:prstDash val="dash"/>
           </a:ln>
         </p:spPr>
+        <p:txBody>
+          <a:bodyPr/>
+          <a:p/>
+        </p:txBody>
       </p:sp>
       <p:sp>
         <p:nvSpPr>
@@ -4908,6 +5062,10 @@
             <a:prstDash val="dash"/>
           </a:ln>
         </p:spPr>
+        <p:txBody>
+          <a:bodyPr/>
+          <a:p/>
+        </p:txBody>
       </p:sp>
       <p:sp>
         <p:nvSpPr>
@@ -4967,6 +5125,10 @@
           </a:solidFill>
           <a:ln/>
         </p:spPr>
+        <p:txBody>
+          <a:bodyPr/>
+          <a:p/>
+        </p:txBody>
       </p:sp>
       <p:sp>
         <p:nvSpPr>
@@ -5029,6 +5191,10 @@
           </a:solidFill>
           <a:ln/>
         </p:spPr>
+        <p:txBody>
+          <a:bodyPr/>
+          <a:p/>
+        </p:txBody>
       </p:sp>
       <p:sp>
         <p:nvSpPr>
@@ -5091,6 +5257,10 @@
           </a:solidFill>
           <a:ln/>
         </p:spPr>
+        <p:txBody>
+          <a:bodyPr/>
+          <a:p/>
+        </p:txBody>
       </p:sp>
       <p:sp>
         <p:nvSpPr>
@@ -5155,6 +5325,10 @@
             <a:prstDash val="dash"/>
           </a:ln>
         </p:spPr>
+        <p:txBody>
+          <a:bodyPr/>
+          <a:p/>
+        </p:txBody>
       </p:sp>
       <p:sp>
         <p:nvSpPr>
@@ -5214,6 +5388,10 @@
           </a:solidFill>
           <a:ln/>
         </p:spPr>
+        <p:txBody>
+          <a:bodyPr/>
+          <a:p/>
+        </p:txBody>
       </p:sp>
       <p:sp>
         <p:nvSpPr>
@@ -5276,6 +5454,10 @@
           </a:solidFill>
           <a:ln/>
         </p:spPr>
+        <p:txBody>
+          <a:bodyPr/>
+          <a:p/>
+        </p:txBody>
       </p:sp>
       <p:sp>
         <p:nvSpPr>
@@ -5338,6 +5520,10 @@
           </a:solidFill>
           <a:ln/>
         </p:spPr>
+        <p:txBody>
+          <a:bodyPr/>
+          <a:p/>
+        </p:txBody>
       </p:sp>
       <p:sp>
         <p:nvSpPr>
@@ -5422,6 +5608,10 @@
             <a:prstDash val="dash"/>
           </a:ln>
         </p:spPr>
+        <p:txBody>
+          <a:bodyPr/>
+          <a:p/>
+        </p:txBody>
       </p:sp>
       <p:sp>
         <p:nvSpPr>
@@ -5481,6 +5671,10 @@
           </a:solidFill>
           <a:ln/>
         </p:spPr>
+        <p:txBody>
+          <a:bodyPr/>
+          <a:p/>
+        </p:txBody>
       </p:sp>
       <p:sp>
         <p:nvSpPr>
@@ -5563,6 +5757,10 @@
           </a:solidFill>
           <a:ln/>
         </p:spPr>
+        <p:txBody>
+          <a:bodyPr/>
+          <a:p/>
+        </p:txBody>
       </p:sp>
       <p:sp>
         <p:nvSpPr>
@@ -5647,6 +5845,10 @@
             <a:prstDash val="dash"/>
           </a:ln>
         </p:spPr>
+        <p:txBody>
+          <a:bodyPr/>
+          <a:p/>
+        </p:txBody>
       </p:sp>
       <p:sp>
         <p:nvSpPr>
@@ -5706,6 +5908,10 @@
           </a:solidFill>
           <a:ln/>
         </p:spPr>
+        <p:txBody>
+          <a:bodyPr/>
+          <a:p/>
+        </p:txBody>
       </p:sp>
       <p:sp>
         <p:nvSpPr>
@@ -5788,6 +5994,10 @@
           </a:solidFill>
           <a:ln/>
         </p:spPr>
+        <p:txBody>
+          <a:bodyPr/>
+          <a:p/>
+        </p:txBody>
       </p:sp>
       <p:sp>
         <p:nvSpPr>
@@ -5870,6 +6080,10 @@
           </a:solidFill>
           <a:ln/>
         </p:spPr>
+        <p:txBody>
+          <a:bodyPr/>
+          <a:p/>
+        </p:txBody>
       </p:sp>
       <p:sp>
         <p:nvSpPr>
@@ -5952,6 +6166,10 @@
           </a:solidFill>
           <a:ln/>
         </p:spPr>
+        <p:txBody>
+          <a:bodyPr/>
+          <a:p/>
+        </p:txBody>
       </p:sp>
       <p:sp>
         <p:nvSpPr>
@@ -6034,6 +6252,10 @@
           </a:solidFill>
           <a:ln/>
         </p:spPr>
+        <p:txBody>
+          <a:bodyPr/>
+          <a:p/>
+        </p:txBody>
       </p:sp>
       <p:sp>
         <p:nvSpPr>
@@ -6112,6 +6334,10 @@
             <a:prstDash val="solid"/>
           </a:ln>
         </p:spPr>
+        <p:txBody>
+          <a:bodyPr/>
+          <a:p/>
+        </p:txBody>
       </p:sp>
       <p:sp>
         <p:nvSpPr>
@@ -6176,6 +6402,10 @@
             <a:prstDash val="solid"/>
           </a:ln>
         </p:spPr>
+        <p:txBody>
+          <a:bodyPr/>
+          <a:p/>
+        </p:txBody>
       </p:sp>
       <p:sp>
         <p:nvSpPr>
@@ -6240,6 +6470,10 @@
             <a:prstDash val="solid"/>
           </a:ln>
         </p:spPr>
+        <p:txBody>
+          <a:bodyPr/>
+          <a:p/>
+        </p:txBody>
       </p:sp>
       <p:sp>
         <p:nvSpPr>
@@ -6304,6 +6538,10 @@
             <a:prstDash val="solid"/>
           </a:ln>
         </p:spPr>
+        <p:txBody>
+          <a:bodyPr/>
+          <a:p/>
+        </p:txBody>
       </p:sp>
       <p:sp>
         <p:nvSpPr>
@@ -6368,6 +6606,10 @@
             <a:prstDash val="solid"/>
           </a:ln>
         </p:spPr>
+        <p:txBody>
+          <a:bodyPr/>
+          <a:p/>
+        </p:txBody>
       </p:sp>
       <p:sp>
         <p:nvSpPr>
@@ -6432,6 +6674,10 @@
             <a:prstDash val="solid"/>
           </a:ln>
         </p:spPr>
+        <p:txBody>
+          <a:bodyPr/>
+          <a:p/>
+        </p:txBody>
       </p:sp>
       <p:sp>
         <p:nvSpPr>
@@ -6496,6 +6742,10 @@
             <a:prstDash val="solid"/>
           </a:ln>
         </p:spPr>
+        <p:txBody>
+          <a:bodyPr/>
+          <a:p/>
+        </p:txBody>
       </p:sp>
       <p:sp>
         <p:nvSpPr>
@@ -6560,6 +6810,10 @@
             <a:prstDash val="solid"/>
           </a:ln>
         </p:spPr>
+        <p:txBody>
+          <a:bodyPr/>
+          <a:p/>
+        </p:txBody>
       </p:sp>
       <p:sp>
         <p:nvSpPr>
@@ -6693,6 +6947,10 @@
           </a:solidFill>
           <a:ln/>
         </p:spPr>
+        <p:txBody>
+          <a:bodyPr/>
+          <a:p/>
+        </p:txBody>
       </p:sp>
       <p:sp>
         <p:nvSpPr>
@@ -6757,6 +7015,10 @@
             <a:prstDash val="solid"/>
           </a:ln>
         </p:spPr>
+        <p:txBody>
+          <a:bodyPr/>
+          <a:p/>
+        </p:txBody>
       </p:sp>
       <p:sp>
         <p:nvSpPr>
@@ -7301,6 +7563,10 @@
             <a:prstDash val="solid"/>
           </a:ln>
         </p:spPr>
+        <p:txBody>
+          <a:bodyPr/>
+          <a:p/>
+        </p:txBody>
       </p:sp>
       <p:sp>
         <p:nvSpPr>
@@ -7635,6 +7901,10 @@
             <a:prstDash val="solid"/>
           </a:ln>
         </p:spPr>
+        <p:txBody>
+          <a:bodyPr/>
+          <a:p/>
+        </p:txBody>
       </p:sp>
       <p:sp>
         <p:nvSpPr>
@@ -7692,6 +7962,134 @@
               <a:t>the agent isn't the product — the governed platform that makes it 21 CFR Part 11 / GxP-defensible and deployable on AWS is.</a:t>
             </a:r>
             <a:endParaRPr lang="en-US" sz="1400" dirty="0"/>
+          </a:p>
+        </p:txBody>
+      </p:sp>
+    </p:spTree>
+  </p:cSld>
+  <p:clrMapOvr>
+    <a:masterClrMapping/>
+  </p:clrMapOvr>
+</p:sld>
+</file>
+
+<file path=ppt/slides/slide7.xml><?xml version="1.0" encoding="utf-8"?>
+<p:sld xmlns:a="http://schemas.openxmlformats.org/drawingml/2006/main" xmlns:p="http://schemas.openxmlformats.org/presentationml/2006/main" xmlns:r="http://schemas.openxmlformats.org/officeDocument/2006/relationships">
+  <p:cSld>
+    <p:spTree>
+      <p:nvGrpSpPr>
+        <p:cNvPr id="1" name=""/>
+        <p:cNvGrpSpPr/>
+        <p:nvPr/>
+      </p:nvGrpSpPr>
+      <p:grpSpPr/>
+      <p:sp>
+        <p:nvSpPr>
+          <p:cNvPr id="2" name="Rectangle 1"/>
+          <p:cNvSpPr/>
+          <p:nvPr/>
+        </p:nvSpPr>
+        <p:spPr>
+          <a:xfrm>
+            <a:off x="0" y="0"/>
+            <a:ext cx="12192000" cy="6858000"/>
+          </a:xfrm>
+          <a:prstGeom prst="rect">
+            <a:avLst/>
+          </a:prstGeom>
+          <a:solidFill>
+            <a:srgbClr val="232F3E"/>
+          </a:solidFill>
+          <a:ln>
+            <a:noFill/>
+          </a:ln>
+          <a:effectLst/>
+        </p:spPr>
+        <p:style>
+          <a:lnRef idx="1">
+            <a:schemeClr val="accent1"/>
+          </a:lnRef>
+          <a:fillRef idx="3">
+            <a:schemeClr val="accent1"/>
+          </a:fillRef>
+          <a:effectRef idx="2">
+            <a:schemeClr val="accent1"/>
+          </a:effectRef>
+          <a:fontRef idx="minor">
+            <a:schemeClr val="lt1"/>
+          </a:fontRef>
+        </p:style>
+        <p:txBody>
+          <a:bodyPr rtlCol="0" anchor="ctr"/>
+          <a:lstStyle/>
+          <a:p>
+            <a:pPr algn="ctr"/>
+          </a:p>
+        </p:txBody>
+      </p:sp>
+      <p:sp>
+        <p:nvSpPr>
+          <p:cNvPr id="3" name="TextBox 2"/>
+          <p:cNvSpPr txBox="1"/>
+          <p:nvPr/>
+        </p:nvSpPr>
+        <p:spPr>
+          <a:xfrm>
+            <a:off x="548640" y="640080"/>
+            <a:ext cx="11094720" cy="914400"/>
+          </a:xfrm>
+          <a:prstGeom prst="rect">
+            <a:avLst/>
+          </a:prstGeom>
+          <a:noFill/>
+        </p:spPr>
+        <p:txBody>
+          <a:bodyPr wrap="none">
+            <a:spAutoFit/>
+          </a:bodyPr>
+          <a:lstStyle/>
+          <a:p>
+            <a:r>
+              <a:rPr sz="3000" b="1">
+                <a:solidFill>
+                  <a:srgbClr val="FF9900"/>
+                </a:solidFill>
+              </a:rPr>
+              <a:t>Disclaimer &amp; shared responsibility</a:t>
+            </a:r>
+          </a:p>
+        </p:txBody>
+      </p:sp>
+      <p:sp>
+        <p:nvSpPr>
+          <p:cNvPr id="4" name="TextBox 3"/>
+          <p:cNvSpPr txBox="1"/>
+          <p:nvPr/>
+        </p:nvSpPr>
+        <p:spPr>
+          <a:xfrm>
+            <a:off x="640080" y="1828800"/>
+            <a:ext cx="10911840" cy="3108960"/>
+          </a:xfrm>
+          <a:prstGeom prst="rect">
+            <a:avLst/>
+          </a:prstGeom>
+          <a:noFill/>
+        </p:spPr>
+        <p:txBody>
+          <a:bodyPr wrap="square">
+            <a:spAutoFit/>
+          </a:bodyPr>
+          <a:lstStyle/>
+          <a:p>
+            <a:r>
+              <a:rPr sz="1600">
+                <a:solidFill>
+                  <a:srgbClr val="FFFFFF"/>
+                </a:solidFill>
+              </a:rPr>
+              <a:t>Reference accelerator - not an AWS service, not AWS-supported software, not a compliance certification, and not production-ready for regulated data without customer-specific engineering, testing, authorization, and operational ownership. Built on AWS; not affiliated with or endorsed by Amazon Web Services.</a:t>
+            </a:r>
           </a:p>
         </p:txBody>
       </p:sp>

</xml_diff>